<commit_message>
viz: add any-N,M step-by-step deck visual, XL/inventory figures, standalone HTML
- make_anynm.py: 7-step any-N,M pipeline build frames (pre/net/post zones,
  scalar->R^d embed and R^d->1 head labels, d/L annotations); GIF + final
- deck: 7 arrow-key build slides on slide 9; Exp 15 XL detail + model
  inventory figures; remove next-steps line from conclusion
- pipeline_solver_vs_nn: CBS planning + suboptimal-paths wording
- make_pptx.py: mirror md (30 slides) incl build-frame loop + speaker notes
- standalone single-file HTML (base64-inlined assets); refresh package zip
</commit_message>
<xml_diff>
--- a/presentation/slides_claude.pptx
+++ b/presentation/slides_claude.pptx
@@ -29,6 +29,12 @@
     <p:sldId id="277" r:id="rId29"/>
     <p:sldId id="278" r:id="rId30"/>
     <p:sldId id="279" r:id="rId31"/>
+    <p:sldId id="280" r:id="rId32"/>
+    <p:sldId id="281" r:id="rId33"/>
+    <p:sldId id="282" r:id="rId34"/>
+    <p:sldId id="283" r:id="rId35"/>
+    <p:sldId id="284" r:id="rId36"/>
+    <p:sldId id="285" r:id="rId37"/>
   </p:sldIdLst>
   <p:sldSz cx="12191695" cy="6858000" type="screen4x3"/>
   <p:notesSz cx="6858000" cy="9144000"/>
@@ -595,7 +601,7 @@
           <a:lstStyle/>
           <a:p>
             <a:r>
-              <a:t>Identical except width/depth. In-distribution the small model is better and faster (big overfits, Exp 12); at extreme extrapolation the big one generalizes better (Exp 15).</a:t>
+              <a:t>Advance with the arrow keys. Pre = data prep (instance → D,G). Net = shared-weight transformer: embed each scalar → ℝ^d token (N×M grid), row+column attention ×L, per-token logit ℝ^d→1, column softmax. Post = argmax decode. G is sum-pooled per goal and ADDED into the D tokens (context, not extra tokens) → output stays N×M. d and L are fixed; the token count N×M grows with the instance — no fixed-size vector.</a:t>
             </a:r>
           </a:p>
         </p:txBody>
@@ -665,7 +671,7 @@
           <a:lstStyle/>
           <a:p>
             <a:r>
-              <a:t>Generate instances, run the solver, store D,G,Y (reject unreachable/over-budget). Train one universal model on many (N,M) shapes. Evaluate offline (accuracy) and — what matters — true execution cost (NN→ordering→CBS vs solver). Code: build_dataset.py, train.py, full_pipeline_eval.py, tests/.</a:t>
+              <a:t>Advance with the arrow keys. Pre = data prep (instance → D,G). Net = shared-weight transformer: embed each scalar → ℝ^d token (N×M grid), row+column attention ×L, per-token logit ℝ^d→1, column softmax. Post = argmax decode. G is sum-pooled per goal and ADDED into the D tokens (context, not extra tokens) → output stays N×M. d and L are fixed; the token count N×M grows with the instance — no fixed-size vector.</a:t>
             </a:r>
           </a:p>
         </p:txBody>
@@ -735,7 +741,7 @@
           <a:lstStyle/>
           <a:p>
             <a:r>
-              <a:t>Across 28 small configs the NN is ~1–6% above optimal; large diverse model mean 1.020. Most disagreements are cost-equivalent ties (exact-cost match ≫ exact-allocation match). CBS dominates full-pipeline time, so single-instance speedup is modest; batched it's ~1000×.</a:t>
+              <a:t>Advance with the arrow keys. Pre = data prep (instance → D,G). Net = shared-weight transformer: embed each scalar → ℝ^d token (N×M grid), row+column attention ×L, per-token logit ℝ^d→1, column softmax. Post = argmax decode. G is sum-pooled per goal and ADDED into the D tokens (context, not extra tokens) → output stays N×M. d and L are fixed; the token count N×M grows with the instance — no fixed-size vector.</a:t>
             </a:r>
           </a:p>
         </p:txBody>
@@ -805,7 +811,7 @@
           <a:lstStyle/>
           <a:p>
             <a:r>
-              <a:t>The 4 standard RobustMCPF benchmark maps. Only maze and room carry corridor/room structure — that distinction drives the next results.</a:t>
+              <a:t>Advance with the arrow keys. Pre = data prep (instance → D,G). Net = shared-weight transformer: embed each scalar → ℝ^d token (N×M grid), row+column attention ×L, per-token logit ℝ^d→1, column softmax. Post = argmax decode. G is sum-pooled per goal and ADDED into the D tokens (context, not extra tokens) → output stays N×M. d and L are fixed; the token count N×M grows with the instance — no fixed-size vector.</a:t>
             </a:r>
           </a:p>
         </p:txBody>
@@ -875,7 +881,7 @@
           <a:lstStyle/>
           <a:p>
             <a:r>
-              <a:t>(a) small model zero-shot on real maps at small N/M = 1.019, but at large N/M fails (1.246 vs map-trained 1.048); scissors at M=30 — more agents hurt the old model (1.28→1.44), help the in-range one (1.10→1.05): generalizes across SHAPE, not SCALE. (b) random-grid training ties fixed-map everywhere except the maze (1.029 vs 1.127): random walls never make corridors. (c) at N≤50/M≤100 the big model extrapolates best (1.208 vs 1.244), speedup 5.9–9.4×.</a:t>
+              <a:t>Advance with the arrow keys. Pre = data prep (instance → D,G). Net = shared-weight transformer: embed each scalar → ℝ^d token (N×M grid), row+column attention ×L, per-token logit ℝ^d→1, column softmax. Post = argmax decode. G is sum-pooled per goal and ADDED into the D tokens (context, not extra tokens) → output stays N×M. d and L are fixed; the token count N×M grows with the instance — no fixed-size vector.</a:t>
             </a:r>
           </a:p>
         </p:txBody>
@@ -945,7 +951,7 @@
           <a:lstStyle/>
           <a:p>
             <a:r>
-              <a:t>NN replaces only allocation, so it wins where allocation/TSP cost dominates and many instances are solved: big problems (5.9–9.4× at ~20% overhead), batched inference, unstructured maps. The exact solver still wins on tiny/exactness-critical/unseen-structured instances.</a:t>
+              <a:t>Advance with the arrow keys. Pre = data prep (instance → D,G). Net = shared-weight transformer: embed each scalar → ℝ^d token (N×M grid), row+column attention ×L, per-token logit ℝ^d→1, column softmax. Post = argmax decode. G is sum-pooled per goal and ADDED into the D tokens (context, not extra tokens) → output stays N×M. d and L are fixed; the token count N×M grows with the instance — no fixed-size vector.</a:t>
             </a:r>
           </a:p>
         </p:txBody>
@@ -1015,7 +1021,7 @@
           <a:lstStyle/>
           <a:p>
             <a:r>
-              <a:t>Real run of model A on the room map. Both reach cost 62, but the NN sends the two right-side goals to a different agent than the solver — CBS executes it collision-free at the same cost. A vivid example of the cost-equivalent ties behind the high exact-match rates. (GIF animates in PowerPoint slideshow; static side-by-side is assets/demo_nn_vs_solver.png.)</a:t>
+              <a:t>Advance with the arrow keys. Pre = data prep (instance → D,G). Net = shared-weight transformer: embed each scalar → ℝ^d token (N×M grid), row+column attention ×L, per-token logit ℝ^d→1, column softmax. Post = argmax decode. G is sum-pooled per goal and ADDED into the D tokens (context, not extra tokens) → output stays N×M. d and L are fixed; the token count N×M grows with the instance — no fixed-size vector.</a:t>
             </a:r>
           </a:p>
         </p:txBody>
@@ -1085,7 +1091,7 @@
           <a:lstStyle/>
           <a:p>
             <a:r>
-              <a:t>Recap the 4 messages. Future work: tour-aware loss + a learned goal-ordering head.</a:t>
+              <a:t>Generate instances, run the solver, store D,G,Y (reject unreachable/over-budget). Train one universal model on many (N,M) shapes. Evaluate offline (accuracy) and — what matters — true execution cost (NN→ordering→CBS vs solver). Code: build_dataset.py, train.py, full_pipeline_eval.py, tests/.</a:t>
             </a:r>
           </a:p>
         </p:txBody>
@@ -1155,7 +1161,7 @@
           <a:lstStyle/>
           <a:p>
             <a:r>
-              <a:t>Keep the backup slides ready for likely questions.</a:t>
+              <a:t>Identical except width/depth. In-distribution the small model is better and faster (big overfits, Exp 12); at extreme extrapolation the big one generalizes better (Exp 15).</a:t>
             </a:r>
           </a:p>
         </p:txBody>
@@ -1225,7 +1231,7 @@
           <a:lstStyle/>
           <a:p>
             <a:r>
-              <a:t>CE drives imitation; MinSum prevents degenerate uniform predictions early. Code: model/losses.py.</a:t>
+              <a:t>Two axes: the net (h128 vs h256) and the training data. A = original small-scale model (random small grids). B = trained on the 4 real benchmark maps; C copies B's recipe but trains on random 32×32 grids (0–50% walls) — a controlled data swap. Train sizes: A ≈840k, B &amp; C ≈720k.</a:t>
             </a:r>
           </a:p>
         </p:txBody>
@@ -1365,7 +1371,7 @@
           <a:lstStyle/>
           <a:p>
             <a:r>
-              <a:t>Difficulty gradient is horizontal — driven by M (goals), nearly flat in N. Worst cell still within ~5%.</a:t>
+              <a:t>Across 28 small configs the NN is ~1–6% above optimal; large diverse model mean 1.020. Most disagreements are cost-equivalent ties (exact-cost match ≫ exact-allocation match). CBS dominates full-pipeline time, so single-instance speedup is modest; batched it's ~1000×.</a:t>
             </a:r>
           </a:p>
         </p:txBody>
@@ -1435,7 +1441,7 @@
           <a:lstStyle/>
           <a:p>
             <a:r>
-              <a:t>Val loss bottoms ~epoch 22 then rises; best-val-loss checkpointing = effective early stopping. Explains why the big model overfits in-distribution but generalizes better far-OOD.</a:t>
+              <a:t>The 4 standard RobustMCPF benchmark maps. Only maze and room carry corridor/room structure — that distinction drives the next results.</a:t>
             </a:r>
           </a:p>
         </p:txBody>
@@ -1505,7 +1511,7 @@
           <a:lstStyle/>
           <a:p>
             <a:r>
-              <a:t>Random Bernoulli walls ≈ empty/random/room statistically, but never produce long corridors → the random-trained model never learned to thread them; the entire fixed-vs-random gap is the maze (worst cell maze n5m30: 1.075 vs 1.362).</a:t>
+              <a:t>(a) small model zero-shot on real maps at small N/M = 1.019, but at large N/M fails (1.246 vs map-trained 1.048); scissors at M=30 — more agents hurt the old model (1.28→1.44), help the in-range one (1.10→1.05): generalizes across SHAPE, not SCALE. (b) random-grid training ties fixed-map everywhere except the maze (1.029 vs 1.127): random walls never make corridors. (c) at N≤50/M≤100 the big model extrapolates best (1.208 vs 1.244), speedup 5.9–9.4×.</a:t>
             </a:r>
           </a:p>
         </p:txBody>
@@ -1575,7 +1581,7 @@
           <a:lstStyle/>
           <a:p>
             <a:r>
-              <a:t>Code: evaluation/evaluate.py (offline), full_pipeline_eval.py (execution cost).</a:t>
+              <a:t>Zero-shot XL toward the paper's N≤50/M≤100. Verdict flips vs in-distribution (Exp 12): the capacity that overfit in range is the better generalizer at scale — h256 1.208 vs h128 1.244, worst-case gap roughly halved (224→124). M=75 hardest for both; maze easiest (≈1.15–1.18). Speedup 5.9–9.4× as LKH's TSP grows. Numbers: RESULTS.md Exp 15.</a:t>
             </a:r>
           </a:p>
         </p:txBody>
@@ -1645,7 +1651,357 @@
           <a:lstStyle/>
           <a:p>
             <a:r>
-              <a:t>Code: full_pipeline_eval.order_goals. Levers to push quality + remove the last classical bottleneck.</a:t>
+              <a:t>NN replaces only allocation, so it wins where allocation/TSP cost dominates and many instances are solved: big problems (5.9–9.4× at ~20% overhead), batched inference, unstructured maps. The exact solver still wins on tiny/exactness-critical/unseen-structured instances.</a:t>
+            </a:r>
+          </a:p>
+        </p:txBody>
+      </p:sp>
+      <p:sp>
+        <p:nvSpPr>
+          <p:cNvPr id="4" name="Slide Number Placeholder 3"/>
+          <p:cNvSpPr>
+            <a:spLocks noGrp="1"/>
+          </p:cNvSpPr>
+          <p:nvPr>
+            <p:ph type="sldNum" idx="5" sz="quarter"/>
+          </p:nvPr>
+        </p:nvSpPr>
+        <p:spPr/>
+      </p:sp>
+    </p:spTree>
+  </p:cSld>
+  <p:clrMapOvr>
+    <a:masterClrMapping/>
+  </p:clrMapOvr>
+</p:notes>
+</file>
+
+<file path=ppt/notesSlides/notesSlide25.xml><?xml version="1.0" encoding="utf-8"?>
+<p:notes xmlns:a="http://schemas.openxmlformats.org/drawingml/2006/main" xmlns:p="http://schemas.openxmlformats.org/presentationml/2006/main" xmlns:r="http://schemas.openxmlformats.org/officeDocument/2006/relationships">
+  <p:cSld>
+    <p:spTree>
+      <p:nvGrpSpPr>
+        <p:cNvPr id="1" name=""/>
+        <p:cNvGrpSpPr/>
+        <p:nvPr/>
+      </p:nvGrpSpPr>
+      <p:grpSpPr>
+        <a:xfrm>
+          <a:off x="0" y="0"/>
+          <a:ext cx="0" cy="0"/>
+          <a:chOff x="0" y="0"/>
+          <a:chExt cx="0" cy="0"/>
+        </a:xfrm>
+      </p:grpSpPr>
+      <p:sp>
+        <p:nvSpPr>
+          <p:cNvPr id="2" name="Slide Image Placeholder 1"/>
+          <p:cNvSpPr>
+            <a:spLocks noGrp="1"/>
+          </p:cNvSpPr>
+          <p:nvPr>
+            <p:ph type="sldImg" idx="2"/>
+          </p:nvPr>
+        </p:nvSpPr>
+        <p:spPr/>
+      </p:sp>
+      <p:sp>
+        <p:nvSpPr>
+          <p:cNvPr id="3" name="Notes Placeholder 2"/>
+          <p:cNvSpPr>
+            <a:spLocks noGrp="1"/>
+          </p:cNvSpPr>
+          <p:nvPr>
+            <p:ph type="body" idx="3" sz="quarter"/>
+          </p:nvPr>
+        </p:nvSpPr>
+        <p:spPr/>
+        <p:txBody>
+          <a:bodyPr/>
+          <a:lstStyle/>
+          <a:p>
+            <a:r>
+              <a:t>Real run of model A on the room map. Both reach cost 62, but the NN sends the two right-side goals to a different agent than the solver — CBS executes it collision-free at the same cost. A vivid example of the cost-equivalent ties behind the high exact-match rates. (GIF animates in PowerPoint slideshow; static side-by-side is assets/demo_nn_vs_solver.png.)</a:t>
+            </a:r>
+          </a:p>
+        </p:txBody>
+      </p:sp>
+      <p:sp>
+        <p:nvSpPr>
+          <p:cNvPr id="4" name="Slide Number Placeholder 3"/>
+          <p:cNvSpPr>
+            <a:spLocks noGrp="1"/>
+          </p:cNvSpPr>
+          <p:nvPr>
+            <p:ph type="sldNum" idx="5" sz="quarter"/>
+          </p:nvPr>
+        </p:nvSpPr>
+        <p:spPr/>
+      </p:sp>
+    </p:spTree>
+  </p:cSld>
+  <p:clrMapOvr>
+    <a:masterClrMapping/>
+  </p:clrMapOvr>
+</p:notes>
+</file>
+
+<file path=ppt/notesSlides/notesSlide26.xml><?xml version="1.0" encoding="utf-8"?>
+<p:notes xmlns:a="http://schemas.openxmlformats.org/drawingml/2006/main" xmlns:p="http://schemas.openxmlformats.org/presentationml/2006/main" xmlns:r="http://schemas.openxmlformats.org/officeDocument/2006/relationships">
+  <p:cSld>
+    <p:spTree>
+      <p:nvGrpSpPr>
+        <p:cNvPr id="1" name=""/>
+        <p:cNvGrpSpPr/>
+        <p:nvPr/>
+      </p:nvGrpSpPr>
+      <p:grpSpPr>
+        <a:xfrm>
+          <a:off x="0" y="0"/>
+          <a:ext cx="0" cy="0"/>
+          <a:chOff x="0" y="0"/>
+          <a:chExt cx="0" cy="0"/>
+        </a:xfrm>
+      </p:grpSpPr>
+      <p:sp>
+        <p:nvSpPr>
+          <p:cNvPr id="2" name="Slide Image Placeholder 1"/>
+          <p:cNvSpPr>
+            <a:spLocks noGrp="1"/>
+          </p:cNvSpPr>
+          <p:nvPr>
+            <p:ph type="sldImg" idx="2"/>
+          </p:nvPr>
+        </p:nvSpPr>
+        <p:spPr/>
+      </p:sp>
+      <p:sp>
+        <p:nvSpPr>
+          <p:cNvPr id="3" name="Notes Placeholder 2"/>
+          <p:cNvSpPr>
+            <a:spLocks noGrp="1"/>
+          </p:cNvSpPr>
+          <p:nvPr>
+            <p:ph type="body" idx="3" sz="quarter"/>
+          </p:nvPr>
+        </p:nvSpPr>
+        <p:spPr/>
+        <p:txBody>
+          <a:bodyPr/>
+          <a:lstStyle/>
+          <a:p>
+            <a:r>
+              <a:t>Recap the 4 messages.</a:t>
+            </a:r>
+          </a:p>
+        </p:txBody>
+      </p:sp>
+      <p:sp>
+        <p:nvSpPr>
+          <p:cNvPr id="4" name="Slide Number Placeholder 3"/>
+          <p:cNvSpPr>
+            <a:spLocks noGrp="1"/>
+          </p:cNvSpPr>
+          <p:nvPr>
+            <p:ph type="sldNum" idx="5" sz="quarter"/>
+          </p:nvPr>
+        </p:nvSpPr>
+        <p:spPr/>
+      </p:sp>
+    </p:spTree>
+  </p:cSld>
+  <p:clrMapOvr>
+    <a:masterClrMapping/>
+  </p:clrMapOvr>
+</p:notes>
+</file>
+
+<file path=ppt/notesSlides/notesSlide27.xml><?xml version="1.0" encoding="utf-8"?>
+<p:notes xmlns:a="http://schemas.openxmlformats.org/drawingml/2006/main" xmlns:p="http://schemas.openxmlformats.org/presentationml/2006/main" xmlns:r="http://schemas.openxmlformats.org/officeDocument/2006/relationships">
+  <p:cSld>
+    <p:spTree>
+      <p:nvGrpSpPr>
+        <p:cNvPr id="1" name=""/>
+        <p:cNvGrpSpPr/>
+        <p:nvPr/>
+      </p:nvGrpSpPr>
+      <p:grpSpPr>
+        <a:xfrm>
+          <a:off x="0" y="0"/>
+          <a:ext cx="0" cy="0"/>
+          <a:chOff x="0" y="0"/>
+          <a:chExt cx="0" cy="0"/>
+        </a:xfrm>
+      </p:grpSpPr>
+      <p:sp>
+        <p:nvSpPr>
+          <p:cNvPr id="2" name="Slide Image Placeholder 1"/>
+          <p:cNvSpPr>
+            <a:spLocks noGrp="1"/>
+          </p:cNvSpPr>
+          <p:nvPr>
+            <p:ph type="sldImg" idx="2"/>
+          </p:nvPr>
+        </p:nvSpPr>
+        <p:spPr/>
+      </p:sp>
+      <p:sp>
+        <p:nvSpPr>
+          <p:cNvPr id="3" name="Notes Placeholder 2"/>
+          <p:cNvSpPr>
+            <a:spLocks noGrp="1"/>
+          </p:cNvSpPr>
+          <p:nvPr>
+            <p:ph type="body" idx="3" sz="quarter"/>
+          </p:nvPr>
+        </p:nvSpPr>
+        <p:spPr/>
+        <p:txBody>
+          <a:bodyPr/>
+          <a:lstStyle/>
+          <a:p>
+            <a:r>
+              <a:t>Keep the backup slides ready for likely questions. Credit RobustMCPF (LKH+CBS) to Yehonatan Kidushim.</a:t>
+            </a:r>
+          </a:p>
+        </p:txBody>
+      </p:sp>
+      <p:sp>
+        <p:nvSpPr>
+          <p:cNvPr id="4" name="Slide Number Placeholder 3"/>
+          <p:cNvSpPr>
+            <a:spLocks noGrp="1"/>
+          </p:cNvSpPr>
+          <p:nvPr>
+            <p:ph type="sldNum" idx="5" sz="quarter"/>
+          </p:nvPr>
+        </p:nvSpPr>
+        <p:spPr/>
+      </p:sp>
+    </p:spTree>
+  </p:cSld>
+  <p:clrMapOvr>
+    <a:masterClrMapping/>
+  </p:clrMapOvr>
+</p:notes>
+</file>
+
+<file path=ppt/notesSlides/notesSlide28.xml><?xml version="1.0" encoding="utf-8"?>
+<p:notes xmlns:a="http://schemas.openxmlformats.org/drawingml/2006/main" xmlns:p="http://schemas.openxmlformats.org/presentationml/2006/main" xmlns:r="http://schemas.openxmlformats.org/officeDocument/2006/relationships">
+  <p:cSld>
+    <p:spTree>
+      <p:nvGrpSpPr>
+        <p:cNvPr id="1" name=""/>
+        <p:cNvGrpSpPr/>
+        <p:nvPr/>
+      </p:nvGrpSpPr>
+      <p:grpSpPr>
+        <a:xfrm>
+          <a:off x="0" y="0"/>
+          <a:ext cx="0" cy="0"/>
+          <a:chOff x="0" y="0"/>
+          <a:chExt cx="0" cy="0"/>
+        </a:xfrm>
+      </p:grpSpPr>
+      <p:sp>
+        <p:nvSpPr>
+          <p:cNvPr id="2" name="Slide Image Placeholder 1"/>
+          <p:cNvSpPr>
+            <a:spLocks noGrp="1"/>
+          </p:cNvSpPr>
+          <p:nvPr>
+            <p:ph type="sldImg" idx="2"/>
+          </p:nvPr>
+        </p:nvSpPr>
+        <p:spPr/>
+      </p:sp>
+      <p:sp>
+        <p:nvSpPr>
+          <p:cNvPr id="3" name="Notes Placeholder 2"/>
+          <p:cNvSpPr>
+            <a:spLocks noGrp="1"/>
+          </p:cNvSpPr>
+          <p:nvPr>
+            <p:ph type="body" idx="3" sz="quarter"/>
+          </p:nvPr>
+        </p:nvSpPr>
+        <p:spPr/>
+        <p:txBody>
+          <a:bodyPr/>
+          <a:lstStyle/>
+          <a:p>
+            <a:r>
+              <a:t>CE drives imitation; MinSum prevents degenerate uniform predictions early. Code: model/losses.py.</a:t>
+            </a:r>
+          </a:p>
+        </p:txBody>
+      </p:sp>
+      <p:sp>
+        <p:nvSpPr>
+          <p:cNvPr id="4" name="Slide Number Placeholder 3"/>
+          <p:cNvSpPr>
+            <a:spLocks noGrp="1"/>
+          </p:cNvSpPr>
+          <p:nvPr>
+            <p:ph type="sldNum" idx="5" sz="quarter"/>
+          </p:nvPr>
+        </p:nvSpPr>
+        <p:spPr/>
+      </p:sp>
+    </p:spTree>
+  </p:cSld>
+  <p:clrMapOvr>
+    <a:masterClrMapping/>
+  </p:clrMapOvr>
+</p:notes>
+</file>
+
+<file path=ppt/notesSlides/notesSlide29.xml><?xml version="1.0" encoding="utf-8"?>
+<p:notes xmlns:a="http://schemas.openxmlformats.org/drawingml/2006/main" xmlns:p="http://schemas.openxmlformats.org/presentationml/2006/main" xmlns:r="http://schemas.openxmlformats.org/officeDocument/2006/relationships">
+  <p:cSld>
+    <p:spTree>
+      <p:nvGrpSpPr>
+        <p:cNvPr id="1" name=""/>
+        <p:cNvGrpSpPr/>
+        <p:nvPr/>
+      </p:nvGrpSpPr>
+      <p:grpSpPr>
+        <a:xfrm>
+          <a:off x="0" y="0"/>
+          <a:ext cx="0" cy="0"/>
+          <a:chOff x="0" y="0"/>
+          <a:chExt cx="0" cy="0"/>
+        </a:xfrm>
+      </p:grpSpPr>
+      <p:sp>
+        <p:nvSpPr>
+          <p:cNvPr id="2" name="Slide Image Placeholder 1"/>
+          <p:cNvSpPr>
+            <a:spLocks noGrp="1"/>
+          </p:cNvSpPr>
+          <p:nvPr>
+            <p:ph type="sldImg" idx="2"/>
+          </p:nvPr>
+        </p:nvSpPr>
+        <p:spPr/>
+      </p:sp>
+      <p:sp>
+        <p:nvSpPr>
+          <p:cNvPr id="3" name="Notes Placeholder 2"/>
+          <p:cNvSpPr>
+            <a:spLocks noGrp="1"/>
+          </p:cNvSpPr>
+          <p:nvPr>
+            <p:ph type="body" idx="3" sz="quarter"/>
+          </p:nvPr>
+        </p:nvSpPr>
+        <p:spPr/>
+        <p:txBody>
+          <a:bodyPr/>
+          <a:lstStyle/>
+          <a:p>
+            <a:r>
+              <a:t>Val loss bottoms ~epoch 22 then rises; best-val-loss checkpointing = effective early stopping. Explains why the big model overfits in-distribution but generalizes better far-OOD.</a:t>
             </a:r>
           </a:p>
         </p:txBody>
@@ -1716,6 +2072,76 @@
           <a:p>
             <a:r>
               <a:t>Multi-agent TSP, not 1-to-1: an agent may take several goals if cheaper (bundle cost 7 beats split 14). This is why the model outputs a per-goal distribution over agents, not a permutation.</a:t>
+            </a:r>
+          </a:p>
+        </p:txBody>
+      </p:sp>
+      <p:sp>
+        <p:nvSpPr>
+          <p:cNvPr id="4" name="Slide Number Placeholder 3"/>
+          <p:cNvSpPr>
+            <a:spLocks noGrp="1"/>
+          </p:cNvSpPr>
+          <p:nvPr>
+            <p:ph type="sldNum" idx="5" sz="quarter"/>
+          </p:nvPr>
+        </p:nvSpPr>
+        <p:spPr/>
+      </p:sp>
+    </p:spTree>
+  </p:cSld>
+  <p:clrMapOvr>
+    <a:masterClrMapping/>
+  </p:clrMapOvr>
+</p:notes>
+</file>
+
+<file path=ppt/notesSlides/notesSlide30.xml><?xml version="1.0" encoding="utf-8"?>
+<p:notes xmlns:a="http://schemas.openxmlformats.org/drawingml/2006/main" xmlns:p="http://schemas.openxmlformats.org/presentationml/2006/main" xmlns:r="http://schemas.openxmlformats.org/officeDocument/2006/relationships">
+  <p:cSld>
+    <p:spTree>
+      <p:nvGrpSpPr>
+        <p:cNvPr id="1" name=""/>
+        <p:cNvGrpSpPr/>
+        <p:nvPr/>
+      </p:nvGrpSpPr>
+      <p:grpSpPr>
+        <a:xfrm>
+          <a:off x="0" y="0"/>
+          <a:ext cx="0" cy="0"/>
+          <a:chOff x="0" y="0"/>
+          <a:chExt cx="0" cy="0"/>
+        </a:xfrm>
+      </p:grpSpPr>
+      <p:sp>
+        <p:nvSpPr>
+          <p:cNvPr id="2" name="Slide Image Placeholder 1"/>
+          <p:cNvSpPr>
+            <a:spLocks noGrp="1"/>
+          </p:cNvSpPr>
+          <p:nvPr>
+            <p:ph type="sldImg" idx="2"/>
+          </p:nvPr>
+        </p:nvSpPr>
+        <p:spPr/>
+      </p:sp>
+      <p:sp>
+        <p:nvSpPr>
+          <p:cNvPr id="3" name="Notes Placeholder 2"/>
+          <p:cNvSpPr>
+            <a:spLocks noGrp="1"/>
+          </p:cNvSpPr>
+          <p:nvPr>
+            <p:ph type="body" idx="3" sz="quarter"/>
+          </p:nvPr>
+        </p:nvSpPr>
+        <p:spPr/>
+        <p:txBody>
+          <a:bodyPr/>
+          <a:lstStyle/>
+          <a:p>
+            <a:r>
+              <a:t>Code: evaluation/evaluate.py (offline), full_pipeline_eval.py (execution cost).</a:t>
             </a:r>
           </a:p>
         </p:txBody>
@@ -5294,69 +5720,14 @@
                 </a:solidFill>
                 <a:latin typeface="Calibri"/>
               </a:rPr>
-              <a:t>Small vs. big model</a:t>
-            </a:r>
-          </a:p>
-        </p:txBody>
-      </p:sp>
-      <p:sp>
-        <p:nvSpPr>
-          <p:cNvPr id="3" name="TextBox 2"/>
-          <p:cNvSpPr txBox="1"/>
-          <p:nvPr/>
-        </p:nvSpPr>
-        <p:spPr>
-          <a:xfrm>
-            <a:off x="640080" y="1325880"/>
-            <a:ext cx="10911535" cy="1143000"/>
-          </a:xfrm>
-          <a:prstGeom prst="rect">
-            <a:avLst/>
-          </a:prstGeom>
-          <a:noFill/>
-        </p:spPr>
-        <p:txBody>
-          <a:bodyPr wrap="square">
-            <a:spAutoFit/>
-          </a:bodyPr>
-          <a:lstStyle/>
-          <a:p>
-            <a:pPr>
-              <a:spcAft>
-                <a:spcPts val="400"/>
-              </a:spcAft>
-            </a:pPr>
-            <a:r>
-              <a:rPr sz="2000">
-                <a:solidFill>
-                  <a:srgbClr val="222222"/>
-                </a:solidFill>
-                <a:latin typeface="Calibri"/>
-              </a:rPr>
-              <a:t>•  h128/L6 = 1.2M params   ·   h256/L8 = 6.3M</a:t>
-            </a:r>
-          </a:p>
-          <a:p>
-            <a:pPr>
-              <a:spcAft>
-                <a:spcPts val="400"/>
-              </a:spcAft>
-            </a:pPr>
-            <a:r>
-              <a:rPr sz="2000">
-                <a:solidFill>
-                  <a:srgbClr val="222222"/>
-                </a:solidFill>
-                <a:latin typeface="Calibri"/>
-              </a:rPr>
-              <a:t>•  preview: small wins in-distribution, big wins far out-of-distribution</a:t>
+              <a:t>One model for ANY N, M — step by step</a:t>
             </a:r>
           </a:p>
         </p:txBody>
       </p:sp>
       <p:pic>
         <p:nvPicPr>
-          <p:cNvPr id="4" name="Picture 3" descr="params_bar.png"/>
+          <p:cNvPr id="3" name="Picture 2" descr="anynm_step1.png"/>
           <p:cNvPicPr>
             <a:picLocks noChangeAspect="1"/>
           </p:cNvPicPr>
@@ -5370,8 +5741,8 @@
         </p:blipFill>
         <p:spPr>
           <a:xfrm>
-            <a:off x="3002889" y="2414016"/>
-            <a:ext cx="6185916" cy="4123944"/>
+            <a:off x="548639" y="1877398"/>
+            <a:ext cx="11094415" cy="4109042"/>
           </a:xfrm>
           <a:prstGeom prst="rect">
             <a:avLst/>
@@ -5425,53 +5796,14 @@
                 </a:solidFill>
                 <a:latin typeface="Calibri"/>
               </a:rPr>
-              <a:t>Method</a:t>
-            </a:r>
-          </a:p>
-        </p:txBody>
-      </p:sp>
-      <p:sp>
-        <p:nvSpPr>
-          <p:cNvPr id="3" name="TextBox 2"/>
-          <p:cNvSpPr txBox="1"/>
-          <p:nvPr/>
-        </p:nvSpPr>
-        <p:spPr>
-          <a:xfrm>
-            <a:off x="640080" y="1325880"/>
-            <a:ext cx="10911535" cy="1143000"/>
-          </a:xfrm>
-          <a:prstGeom prst="rect">
-            <a:avLst/>
-          </a:prstGeom>
-          <a:noFill/>
-        </p:spPr>
-        <p:txBody>
-          <a:bodyPr wrap="square">
-            <a:spAutoFit/>
-          </a:bodyPr>
-          <a:lstStyle/>
-          <a:p>
-            <a:pPr>
-              <a:spcAft>
-                <a:spcPts val="400"/>
-              </a:spcAft>
-            </a:pPr>
-            <a:r>
-              <a:rPr sz="2000">
-                <a:solidFill>
-                  <a:srgbClr val="222222"/>
-                </a:solidFill>
-                <a:latin typeface="Calibri"/>
-              </a:rPr>
-              <a:t>•  data: solver labels D,G,Y   ·   train: imitate, mixed-size   ·   eval: offline + true CBS cost</a:t>
+              <a:t>One model for ANY N, M — step by step</a:t>
             </a:r>
           </a:p>
         </p:txBody>
       </p:sp>
       <p:pic>
         <p:nvPicPr>
-          <p:cNvPr id="4" name="Picture 3" descr="method_flow.png"/>
+          <p:cNvPr id="3" name="Picture 2" descr="anynm_step2.png"/>
           <p:cNvPicPr>
             <a:picLocks noChangeAspect="1"/>
           </p:cNvPicPr>
@@ -5485,8 +5817,8 @@
         </p:blipFill>
         <p:spPr>
           <a:xfrm>
-            <a:off x="548639" y="2468514"/>
-            <a:ext cx="11094415" cy="3630899"/>
+            <a:off x="548639" y="1877398"/>
+            <a:ext cx="11094415" cy="4109042"/>
           </a:xfrm>
           <a:prstGeom prst="rect">
             <a:avLst/>
@@ -5540,69 +5872,14 @@
                 </a:solidFill>
                 <a:latin typeface="Calibri"/>
               </a:rPr>
-              <a:t>Results: near the solver, cheaper to run</a:t>
-            </a:r>
-          </a:p>
-        </p:txBody>
-      </p:sp>
-      <p:sp>
-        <p:nvSpPr>
-          <p:cNvPr id="3" name="TextBox 2"/>
-          <p:cNvSpPr txBox="1"/>
-          <p:nvPr/>
-        </p:nvSpPr>
-        <p:spPr>
-          <a:xfrm>
-            <a:off x="640080" y="1325880"/>
-            <a:ext cx="10911535" cy="1143000"/>
-          </a:xfrm>
-          <a:prstGeom prst="rect">
-            <a:avLst/>
-          </a:prstGeom>
-          <a:noFill/>
-        </p:spPr>
-        <p:txBody>
-          <a:bodyPr wrap="square">
-            <a:spAutoFit/>
-          </a:bodyPr>
-          <a:lstStyle/>
-          <a:p>
-            <a:pPr>
-              <a:spcAft>
-                <a:spcPts val="400"/>
-              </a:spcAft>
-            </a:pPr>
-            <a:r>
-              <a:rPr sz="2000">
-                <a:solidFill>
-                  <a:srgbClr val="222222"/>
-                </a:solidFill>
-                <a:latin typeface="Calibri"/>
-              </a:rPr>
-              <a:t>•  execution-cost ratio ~1.02–1.05 · high exact-cost match · 0% infeasible</a:t>
-            </a:r>
-          </a:p>
-          <a:p>
-            <a:pPr>
-              <a:spcAft>
-                <a:spcPts val="400"/>
-              </a:spcAft>
-            </a:pPr>
-            <a:r>
-              <a:rPr sz="2000">
-                <a:solidFill>
-                  <a:srgbClr val="222222"/>
-                </a:solidFill>
-                <a:latin typeface="Calibri"/>
-              </a:rPr>
-              <a:t>•  speedup: a few × single-instance, ~10³× batched (allocation-only)</a:t>
+              <a:t>One model for ANY N, M — step by step</a:t>
             </a:r>
           </a:p>
         </p:txBody>
       </p:sp>
       <p:pic>
         <p:nvPicPr>
-          <p:cNvPr id="4" name="Picture 3" descr="heatmap_cost.png"/>
+          <p:cNvPr id="3" name="Picture 2" descr="anynm_step3.png"/>
           <p:cNvPicPr>
             <a:picLocks noChangeAspect="1"/>
           </p:cNvPicPr>
@@ -5616,8 +5893,8 @@
         </p:blipFill>
         <p:spPr>
           <a:xfrm>
-            <a:off x="2223922" y="2414016"/>
-            <a:ext cx="7743850" cy="4123944"/>
+            <a:off x="548639" y="1877398"/>
+            <a:ext cx="11094415" cy="4109042"/>
           </a:xfrm>
           <a:prstGeom prst="rect">
             <a:avLst/>
@@ -5671,14 +5948,14 @@
                 </a:solidFill>
                 <a:latin typeface="Calibri"/>
               </a:rPr>
-              <a:t>From random grids to real benchmark maps</a:t>
+              <a:t>One model for ANY N, M — step by step</a:t>
             </a:r>
           </a:p>
         </p:txBody>
       </p:sp>
       <p:pic>
         <p:nvPicPr>
-          <p:cNvPr id="3" name="Picture 2" descr="maps_panel.png"/>
+          <p:cNvPr id="3" name="Picture 2" descr="anynm_step4.png"/>
           <p:cNvPicPr>
             <a:picLocks noChangeAspect="1"/>
           </p:cNvPicPr>
@@ -5692,49 +5969,14 @@
         </p:blipFill>
         <p:spPr>
           <a:xfrm>
-            <a:off x="3793711" y="1325880"/>
-            <a:ext cx="4604272" cy="4892040"/>
+            <a:off x="548639" y="1877398"/>
+            <a:ext cx="11094415" cy="4109042"/>
           </a:xfrm>
           <a:prstGeom prst="rect">
             <a:avLst/>
           </a:prstGeom>
         </p:spPr>
       </p:pic>
-      <p:sp>
-        <p:nvSpPr>
-          <p:cNvPr id="4" name="TextBox 3"/>
-          <p:cNvSpPr txBox="1"/>
-          <p:nvPr/>
-        </p:nvSpPr>
-        <p:spPr>
-          <a:xfrm>
-            <a:off x="548640" y="6309360"/>
-            <a:ext cx="11094415" cy="411480"/>
-          </a:xfrm>
-          <a:prstGeom prst="rect">
-            <a:avLst/>
-          </a:prstGeom>
-          <a:noFill/>
-        </p:spPr>
-        <p:txBody>
-          <a:bodyPr wrap="square">
-            <a:spAutoFit/>
-          </a:bodyPr>
-          <a:lstStyle/>
-          <a:p>
-            <a:pPr algn="ctr"/>
-            <a:r>
-              <a:rPr sz="1300" i="1">
-                <a:solidFill>
-                  <a:srgbClr val="444444"/>
-                </a:solidFill>
-                <a:latin typeface="Calibri"/>
-              </a:rPr>
-              <a:t>open → scattered → maze → rooms; only maze/room are truly structured</a:t>
-            </a:r>
-          </a:p>
-        </p:txBody>
-      </p:sp>
     </p:spTree>
   </p:cSld>
   <p:clrMapOvr>
@@ -5782,53 +6024,14 @@
                 </a:solidFill>
                 <a:latin typeface="Calibri"/>
               </a:rPr>
-              <a:t>Results: generalization studies</a:t>
-            </a:r>
-          </a:p>
-        </p:txBody>
-      </p:sp>
-      <p:sp>
-        <p:nvSpPr>
-          <p:cNvPr id="3" name="TextBox 2"/>
-          <p:cNvSpPr txBox="1"/>
-          <p:nvPr/>
-        </p:nvSpPr>
-        <p:spPr>
-          <a:xfrm>
-            <a:off x="640080" y="1325880"/>
-            <a:ext cx="10911535" cy="1143000"/>
-          </a:xfrm>
-          <a:prstGeom prst="rect">
-            <a:avLst/>
-          </a:prstGeom>
-          <a:noFill/>
-        </p:spPr>
-        <p:txBody>
-          <a:bodyPr wrap="square">
-            <a:spAutoFit/>
-          </a:bodyPr>
-          <a:lstStyle/>
-          <a:p>
-            <a:pPr>
-              <a:spcAft>
-                <a:spcPts val="400"/>
-              </a:spcAft>
-            </a:pPr>
-            <a:r>
-              <a:rPr sz="2000">
-                <a:solidFill>
-                  <a:srgbClr val="222222"/>
-                </a:solidFill>
-                <a:latin typeface="Calibri"/>
-              </a:rPr>
-              <a:t>•  transfers across geometry, not scale · random≈fixed training except the maze · XL: 5.9–9.4×</a:t>
+              <a:t>One model for ANY N, M — step by step</a:t>
             </a:r>
           </a:p>
         </p:txBody>
       </p:sp>
       <p:pic>
         <p:nvPicPr>
-          <p:cNvPr id="4" name="Picture 3" descr="scissors_13b.png"/>
+          <p:cNvPr id="3" name="Picture 2" descr="anynm_step5.png"/>
           <p:cNvPicPr>
             <a:picLocks noChangeAspect="1"/>
           </p:cNvPicPr>
@@ -5842,32 +6045,8 @@
         </p:blipFill>
         <p:spPr>
           <a:xfrm>
-            <a:off x="548639" y="2351804"/>
-            <a:ext cx="5410047" cy="3864319"/>
-          </a:xfrm>
-          <a:prstGeom prst="rect">
-            <a:avLst/>
-          </a:prstGeom>
-        </p:spPr>
-      </p:pic>
-      <p:pic>
-        <p:nvPicPr>
-          <p:cNvPr id="5" name="Picture 4" descr="random_vs_fixed_bymap.png"/>
-          <p:cNvPicPr>
-            <a:picLocks noChangeAspect="1"/>
-          </p:cNvPicPr>
-          <p:nvPr/>
-        </p:nvPicPr>
-        <p:blipFill>
-          <a:blip r:embed="rId3"/>
-          <a:stretch>
-            <a:fillRect/>
-          </a:stretch>
-        </p:blipFill>
-        <p:spPr>
-          <a:xfrm>
-            <a:off x="6233007" y="2593324"/>
-            <a:ext cx="5410047" cy="3381279"/>
+            <a:off x="548639" y="1877398"/>
+            <a:ext cx="11094415" cy="4109042"/>
           </a:xfrm>
           <a:prstGeom prst="rect">
             <a:avLst/>
@@ -5921,14 +6100,14 @@
                 </a:solidFill>
                 <a:latin typeface="Calibri"/>
               </a:rPr>
-              <a:t>When to use the NN vs. the exact solver</a:t>
+              <a:t>One model for ANY N, M — step by step</a:t>
             </a:r>
           </a:p>
         </p:txBody>
       </p:sp>
       <p:pic>
         <p:nvPicPr>
-          <p:cNvPr id="3" name="Picture 2" descr="decision_table.png"/>
+          <p:cNvPr id="3" name="Picture 2" descr="anynm_step6.png"/>
           <p:cNvPicPr>
             <a:picLocks noChangeAspect="1"/>
           </p:cNvPicPr>
@@ -5942,8 +6121,8 @@
         </p:blipFill>
         <p:spPr>
           <a:xfrm>
-            <a:off x="548639" y="1380204"/>
-            <a:ext cx="11094415" cy="5103430"/>
+            <a:off x="548639" y="1877398"/>
+            <a:ext cx="11094415" cy="4109042"/>
           </a:xfrm>
           <a:prstGeom prst="rect">
             <a:avLst/>
@@ -5997,14 +6176,14 @@
                 </a:solidFill>
                 <a:latin typeface="Calibri"/>
               </a:rPr>
-              <a:t>Demo: same instance, solver vs NN</a:t>
+              <a:t>One model for ANY N, M — step by step</a:t>
             </a:r>
           </a:p>
         </p:txBody>
       </p:sp>
       <p:pic>
         <p:nvPicPr>
-          <p:cNvPr id="3" name="Picture 2" descr="demo_run_compare.gif"/>
+          <p:cNvPr id="3" name="Picture 2" descr="anynm_step7.png"/>
           <p:cNvPicPr>
             <a:picLocks noChangeAspect="1"/>
           </p:cNvPicPr>
@@ -6018,49 +6197,14 @@
         </p:blipFill>
         <p:spPr>
           <a:xfrm>
-            <a:off x="1815312" y="1325880"/>
-            <a:ext cx="8561069" cy="4892040"/>
+            <a:off x="548639" y="1877398"/>
+            <a:ext cx="11094415" cy="4109042"/>
           </a:xfrm>
           <a:prstGeom prst="rect">
             <a:avLst/>
           </a:prstGeom>
         </p:spPr>
       </p:pic>
-      <p:sp>
-        <p:nvSpPr>
-          <p:cNvPr id="4" name="TextBox 3"/>
-          <p:cNvSpPr txBox="1"/>
-          <p:nvPr/>
-        </p:nvSpPr>
-        <p:spPr>
-          <a:xfrm>
-            <a:off x="548640" y="6309360"/>
-            <a:ext cx="11094415" cy="411480"/>
-          </a:xfrm>
-          <a:prstGeom prst="rect">
-            <a:avLst/>
-          </a:prstGeom>
-          <a:noFill/>
-        </p:spPr>
-        <p:txBody>
-          <a:bodyPr wrap="square">
-            <a:spAutoFit/>
-          </a:bodyPr>
-          <a:lstStyle/>
-          <a:p>
-            <a:pPr algn="ctr"/>
-            <a:r>
-              <a:rPr sz="1300" i="1">
-                <a:solidFill>
-                  <a:srgbClr val="444444"/>
-                </a:solidFill>
-                <a:latin typeface="Calibri"/>
-              </a:rPr>
-              <a:t>different allocation, identical cost (62) — the NN found its own equally-optimal plan</a:t>
-            </a:r>
-          </a:p>
-        </p:txBody>
-      </p:sp>
     </p:spTree>
   </p:cSld>
   <p:clrMapOvr>
@@ -6108,7 +6252,7 @@
                 </a:solidFill>
                 <a:latin typeface="Calibri"/>
               </a:rPr>
-              <a:t>Conclusion</a:t>
+              <a:t>Method</a:t>
             </a:r>
           </a:p>
         </p:txBody>
@@ -6147,59 +6291,35 @@
                 </a:solidFill>
                 <a:latin typeface="Calibri"/>
               </a:rPr>
-              <a:t>•  Problem: optimal allocation (mTSP in MAPF) — combinatorial step scales badly</a:t>
-            </a:r>
-          </a:p>
-          <a:p>
-            <a:pPr>
-              <a:spcAft>
-                <a:spcPts val="400"/>
-              </a:spcAft>
-            </a:pPr>
-            <a:r>
-              <a:rPr sz="2000">
-                <a:solidFill>
-                  <a:srgbClr val="222222"/>
-                </a:solidFill>
-                <a:latin typeface="Calibri"/>
-              </a:rPr>
-              <a:t>•  Idea: a small universal transformer imitates it from distances — near-optimal</a:t>
-            </a:r>
-          </a:p>
-          <a:p>
-            <a:pPr>
-              <a:spcAft>
-                <a:spcPts val="400"/>
-              </a:spcAft>
-            </a:pPr>
-            <a:r>
-              <a:rPr sz="2000">
-                <a:solidFill>
-                  <a:srgbClr val="222222"/>
-                </a:solidFill>
-                <a:latin typeface="Calibri"/>
-              </a:rPr>
-              <a:t>•  Generalizes: any N,M; across scale and (with the right data) geometry</a:t>
-            </a:r>
-          </a:p>
-          <a:p>
-            <a:pPr>
-              <a:spcAft>
-                <a:spcPts val="400"/>
-              </a:spcAft>
-            </a:pPr>
-            <a:r>
-              <a:rPr sz="2000">
-                <a:solidFill>
-                  <a:srgbClr val="222222"/>
-                </a:solidFill>
-                <a:latin typeface="Calibri"/>
-              </a:rPr>
-              <a:t>•  Payoff: 5.9–9.4× at scale, within ~20% of optimal — use where speed/scale matter</a:t>
-            </a:r>
-          </a:p>
-        </p:txBody>
-      </p:sp>
+              <a:t>•  data: solver labels D,G,Y   ·   train: imitate, mixed-size   ·   eval: offline + true CBS cost</a:t>
+            </a:r>
+          </a:p>
+        </p:txBody>
+      </p:sp>
+      <p:pic>
+        <p:nvPicPr>
+          <p:cNvPr id="4" name="Picture 3" descr="method_flow.png"/>
+          <p:cNvPicPr>
+            <a:picLocks noChangeAspect="1"/>
+          </p:cNvPicPr>
+          <p:nvPr/>
+        </p:nvPicPr>
+        <p:blipFill>
+          <a:blip r:embed="rId2"/>
+          <a:stretch>
+            <a:fillRect/>
+          </a:stretch>
+        </p:blipFill>
+        <p:spPr>
+          <a:xfrm>
+            <a:off x="548639" y="2468514"/>
+            <a:ext cx="11094415" cy="3630899"/>
+          </a:xfrm>
+          <a:prstGeom prst="rect">
+            <a:avLst/>
+          </a:prstGeom>
+        </p:spPr>
+      </p:pic>
     </p:spTree>
   </p:cSld>
   <p:clrMapOvr>
@@ -6247,7 +6367,7 @@
                 </a:solidFill>
                 <a:latin typeface="Calibri"/>
               </a:rPr>
-              <a:t>Thank you — questions?</a:t>
+              <a:t>Small vs. big model</a:t>
             </a:r>
           </a:p>
         </p:txBody>
@@ -6286,11 +6406,51 @@
                 </a:solidFill>
                 <a:latin typeface="Calibri"/>
               </a:rPr>
-              <a:t>•  repo: Neural_MCPF_Allocation · RobustMCPF (LKH + CBS)</a:t>
-            </a:r>
-          </a:p>
-        </p:txBody>
-      </p:sp>
+              <a:t>•  h128/L6 = 1.2M params   ·   h256/L8 = 6.3M</a:t>
+            </a:r>
+          </a:p>
+          <a:p>
+            <a:pPr>
+              <a:spcAft>
+                <a:spcPts val="400"/>
+              </a:spcAft>
+            </a:pPr>
+            <a:r>
+              <a:rPr sz="2000">
+                <a:solidFill>
+                  <a:srgbClr val="222222"/>
+                </a:solidFill>
+                <a:latin typeface="Calibri"/>
+              </a:rPr>
+              <a:t>•  preview: small wins in-distribution, big wins far out-of-distribution</a:t>
+            </a:r>
+          </a:p>
+        </p:txBody>
+      </p:sp>
+      <p:pic>
+        <p:nvPicPr>
+          <p:cNvPr id="4" name="Picture 3" descr="params_bar.png"/>
+          <p:cNvPicPr>
+            <a:picLocks noChangeAspect="1"/>
+          </p:cNvPicPr>
+          <p:nvPr/>
+        </p:nvPicPr>
+        <p:blipFill>
+          <a:blip r:embed="rId2"/>
+          <a:stretch>
+            <a:fillRect/>
+          </a:stretch>
+        </p:blipFill>
+        <p:spPr>
+          <a:xfrm>
+            <a:off x="3002889" y="2414016"/>
+            <a:ext cx="6185916" cy="4123944"/>
+          </a:xfrm>
+          <a:prstGeom prst="rect">
+            <a:avLst/>
+          </a:prstGeom>
+        </p:spPr>
+      </p:pic>
     </p:spTree>
   </p:cSld>
   <p:clrMapOvr>
@@ -6338,7 +6498,7 @@
                 </a:solidFill>
                 <a:latin typeface="Calibri"/>
               </a:rPr>
-              <a:t>(Backup) Loss</a:t>
+              <a:t>Our models: architecture × training data (A / B / C)</a:t>
             </a:r>
           </a:p>
         </p:txBody>
@@ -6377,7 +6537,7 @@
                 </a:solidFill>
                 <a:latin typeface="Calibri"/>
               </a:rPr>
-              <a:t>•  L = L_CE + λ·L_MinSum   (λ = 0.1)</a:t>
+              <a:t>•  A = original (small scale)  ·  B = trained on the real maps  ·  C = random-diverse grids</a:t>
             </a:r>
           </a:p>
           <a:p>
@@ -6393,27 +6553,35 @@
                 </a:solidFill>
                 <a:latin typeface="Calibri"/>
               </a:rPr>
-              <a:t>•  CE — per-goal cross-entropy vs the solver (imitation)</a:t>
-            </a:r>
-          </a:p>
-          <a:p>
-            <a:pPr>
-              <a:spcAft>
-                <a:spcPts val="400"/>
-              </a:spcAft>
-            </a:pPr>
-            <a:r>
-              <a:rPr sz="2000">
-                <a:solidFill>
-                  <a:srgbClr val="222222"/>
-                </a:solidFill>
-                <a:latin typeface="Calibri"/>
-              </a:rPr>
-              <a:t>•  MinSum = Σ P·D — mild geometric regularizer</a:t>
-            </a:r>
-          </a:p>
-        </p:txBody>
-      </p:sp>
+              <a:t>•  suffix 1 = small net (h128, 1.2M)  ·  2 = big net (h256, 6.3M)</a:t>
+            </a:r>
+          </a:p>
+        </p:txBody>
+      </p:sp>
+      <p:pic>
+        <p:nvPicPr>
+          <p:cNvPr id="4" name="Picture 3" descr="model_inventory.png"/>
+          <p:cNvPicPr>
+            <a:picLocks noChangeAspect="1"/>
+          </p:cNvPicPr>
+          <p:nvPr/>
+        </p:nvPicPr>
+        <p:blipFill>
+          <a:blip r:embed="rId2"/>
+          <a:stretch>
+            <a:fillRect/>
+          </a:stretch>
+        </p:blipFill>
+        <p:spPr>
+          <a:xfrm>
+            <a:off x="548639" y="2847564"/>
+            <a:ext cx="11094415" cy="3256847"/>
+          </a:xfrm>
+          <a:prstGeom prst="rect">
+            <a:avLst/>
+          </a:prstGeom>
+        </p:spPr>
+      </p:pic>
     </p:spTree>
   </p:cSld>
   <p:clrMapOvr>
@@ -6592,14 +6760,69 @@
                 </a:solidFill>
                 <a:latin typeface="Calibri"/>
               </a:rPr>
-              <a:t>(Backup) Full results — heatmaps</a:t>
+              <a:t>Results: near the solver, cheaper to run</a:t>
+            </a:r>
+          </a:p>
+        </p:txBody>
+      </p:sp>
+      <p:sp>
+        <p:nvSpPr>
+          <p:cNvPr id="3" name="TextBox 2"/>
+          <p:cNvSpPr txBox="1"/>
+          <p:nvPr/>
+        </p:nvSpPr>
+        <p:spPr>
+          <a:xfrm>
+            <a:off x="640080" y="1325880"/>
+            <a:ext cx="10911535" cy="1143000"/>
+          </a:xfrm>
+          <a:prstGeom prst="rect">
+            <a:avLst/>
+          </a:prstGeom>
+          <a:noFill/>
+        </p:spPr>
+        <p:txBody>
+          <a:bodyPr wrap="square">
+            <a:spAutoFit/>
+          </a:bodyPr>
+          <a:lstStyle/>
+          <a:p>
+            <a:pPr>
+              <a:spcAft>
+                <a:spcPts val="400"/>
+              </a:spcAft>
+            </a:pPr>
+            <a:r>
+              <a:rPr sz="2000">
+                <a:solidFill>
+                  <a:srgbClr val="222222"/>
+                </a:solidFill>
+                <a:latin typeface="Calibri"/>
+              </a:rPr>
+              <a:t>•  cost ratio ~1.02–1.05 (≈1–6% above optimal)</a:t>
+            </a:r>
+          </a:p>
+          <a:p>
+            <a:pPr>
+              <a:spcAft>
+                <a:spcPts val="400"/>
+              </a:spcAft>
+            </a:pPr>
+            <a:r>
+              <a:rPr sz="2000">
+                <a:solidFill>
+                  <a:srgbClr val="222222"/>
+                </a:solidFill>
+                <a:latin typeface="Calibri"/>
+              </a:rPr>
+              <a:t>•  exact-cost match ~60–99% — both track M, nearly flat in N</a:t>
             </a:r>
           </a:p>
         </p:txBody>
       </p:sp>
       <p:pic>
         <p:nvPicPr>
-          <p:cNvPr id="3" name="Picture 2" descr="heatmap_cost.png"/>
+          <p:cNvPr id="4" name="Picture 3" descr="heatmap_cost.png"/>
           <p:cNvPicPr>
             <a:picLocks noChangeAspect="1"/>
           </p:cNvPicPr>
@@ -6613,7 +6836,7 @@
         </p:blipFill>
         <p:spPr>
           <a:xfrm>
-            <a:off x="548639" y="2491374"/>
+            <a:off x="548639" y="3035442"/>
             <a:ext cx="5410047" cy="2881090"/>
           </a:xfrm>
           <a:prstGeom prst="rect">
@@ -6623,7 +6846,7 @@
       </p:pic>
       <p:pic>
         <p:nvPicPr>
-          <p:cNvPr id="4" name="Picture 3" descr="heatmap_match.png"/>
+          <p:cNvPr id="5" name="Picture 4" descr="heatmap_match.png"/>
           <p:cNvPicPr>
             <a:picLocks noChangeAspect="1"/>
           </p:cNvPicPr>
@@ -6637,7 +6860,7 @@
         </p:blipFill>
         <p:spPr>
           <a:xfrm>
-            <a:off x="6233007" y="2481361"/>
+            <a:off x="6233007" y="3025429"/>
             <a:ext cx="5410047" cy="2901117"/>
           </a:xfrm>
           <a:prstGeom prst="rect">
@@ -6692,14 +6915,14 @@
                 </a:solidFill>
                 <a:latin typeface="Calibri"/>
               </a:rPr>
-              <a:t>(Backup) Overfitting &amp; small-vs-big</a:t>
+              <a:t>From random grids to real benchmark maps</a:t>
             </a:r>
           </a:p>
         </p:txBody>
       </p:sp>
       <p:pic>
         <p:nvPicPr>
-          <p:cNvPr id="3" name="Picture 2" descr="convergence.png"/>
+          <p:cNvPr id="3" name="Picture 2" descr="maps_panel.png"/>
           <p:cNvPicPr>
             <a:picLocks noChangeAspect="1"/>
           </p:cNvPicPr>
@@ -6713,14 +6936,49 @@
         </p:blipFill>
         <p:spPr>
           <a:xfrm>
-            <a:off x="548639" y="1772786"/>
-            <a:ext cx="11094415" cy="4318266"/>
+            <a:off x="3793711" y="1325880"/>
+            <a:ext cx="4604272" cy="4892040"/>
           </a:xfrm>
           <a:prstGeom prst="rect">
             <a:avLst/>
           </a:prstGeom>
         </p:spPr>
       </p:pic>
+      <p:sp>
+        <p:nvSpPr>
+          <p:cNvPr id="4" name="TextBox 3"/>
+          <p:cNvSpPr txBox="1"/>
+          <p:nvPr/>
+        </p:nvSpPr>
+        <p:spPr>
+          <a:xfrm>
+            <a:off x="548640" y="6309360"/>
+            <a:ext cx="11094415" cy="411480"/>
+          </a:xfrm>
+          <a:prstGeom prst="rect">
+            <a:avLst/>
+          </a:prstGeom>
+          <a:noFill/>
+        </p:spPr>
+        <p:txBody>
+          <a:bodyPr wrap="square">
+            <a:spAutoFit/>
+          </a:bodyPr>
+          <a:lstStyle/>
+          <a:p>
+            <a:pPr algn="ctr"/>
+            <a:r>
+              <a:rPr sz="1300" i="1">
+                <a:solidFill>
+                  <a:srgbClr val="444444"/>
+                </a:solidFill>
+                <a:latin typeface="Calibri"/>
+              </a:rPr>
+              <a:t>open → scattered → maze → rooms; only maze/room are truly structured</a:t>
+            </a:r>
+          </a:p>
+        </p:txBody>
+      </p:sp>
     </p:spTree>
   </p:cSld>
   <p:clrMapOvr>
@@ -6768,14 +7026,14 @@
                 </a:solidFill>
                 <a:latin typeface="Calibri"/>
               </a:rPr>
-              <a:t>(Backup) Why random training fails on the maze</a:t>
+              <a:t>Results: generalization studies</a:t>
             </a:r>
           </a:p>
         </p:txBody>
       </p:sp>
       <p:pic>
         <p:nvPicPr>
-          <p:cNvPr id="3" name="Picture 2" descr="maps_panel.png"/>
+          <p:cNvPr id="3" name="Picture 2" descr="scissors_13b.png"/>
           <p:cNvPicPr>
             <a:picLocks noChangeAspect="1"/>
           </p:cNvPicPr>
@@ -6789,8 +7047,8 @@
         </p:blipFill>
         <p:spPr>
           <a:xfrm>
-            <a:off x="800920" y="1325880"/>
-            <a:ext cx="4905487" cy="5212080"/>
+            <a:off x="548639" y="1999760"/>
+            <a:ext cx="5410047" cy="3864319"/>
           </a:xfrm>
           <a:prstGeom prst="rect">
             <a:avLst/>
@@ -6813,7 +7071,7 @@
         </p:blipFill>
         <p:spPr>
           <a:xfrm>
-            <a:off x="5980727" y="2241280"/>
+            <a:off x="6233007" y="2241280"/>
             <a:ext cx="5410047" cy="3381279"/>
           </a:xfrm>
           <a:prstGeom prst="rect">
@@ -6868,7 +7126,7 @@
                 </a:solidFill>
                 <a:latin typeface="Calibri"/>
               </a:rPr>
-              <a:t>(Backup) Metrics</a:t>
+              <a:t>Pushing further: zero-shot XL extrapolation (Exp 15)</a:t>
             </a:r>
           </a:p>
         </p:txBody>
@@ -6907,7 +7165,7 @@
                 </a:solidFill>
                 <a:latin typeface="Calibri"/>
               </a:rPr>
-              <a:t>•  Offline — allocation agreement (per-goal / full-assignment accuracy)</a:t>
+              <a:t>•  B models run zero-shot at N∈{20,35,50} × M∈{50,75,100} (no retraining)</a:t>
             </a:r>
           </a:p>
           <a:p>
@@ -6923,23 +7181,66 @@
                 </a:solidFill>
                 <a:latin typeface="Calibri"/>
               </a:rPr>
-              <a:t>•  Execution cost — true CBS path-length ratio (NN / solver)</a:t>
-            </a:r>
-          </a:p>
-          <a:p>
-            <a:pPr>
-              <a:spcAft>
-                <a:spcPts val="400"/>
-              </a:spcAft>
-            </a:pPr>
-            <a:r>
-              <a:rPr sz="2000">
-                <a:solidFill>
-                  <a:srgbClr val="222222"/>
+              <a:t>•  the bigger model (h256) wins out-of-distribution (1.208 vs 1.244), and inference is 5.9–9.4× faster than the solver</a:t>
+            </a:r>
+          </a:p>
+        </p:txBody>
+      </p:sp>
+      <p:pic>
+        <p:nvPicPr>
+          <p:cNvPr id="4" name="Picture 3" descr="xl_heatmaps_speedup.png"/>
+          <p:cNvPicPr>
+            <a:picLocks noChangeAspect="1"/>
+          </p:cNvPicPr>
+          <p:nvPr/>
+        </p:nvPicPr>
+        <p:blipFill>
+          <a:blip r:embed="rId2"/>
+          <a:stretch>
+            <a:fillRect/>
+          </a:stretch>
+        </p:blipFill>
+        <p:spPr>
+          <a:xfrm>
+            <a:off x="661699" y="2414016"/>
+            <a:ext cx="10868297" cy="3803904"/>
+          </a:xfrm>
+          <a:prstGeom prst="rect">
+            <a:avLst/>
+          </a:prstGeom>
+        </p:spPr>
+      </p:pic>
+      <p:sp>
+        <p:nvSpPr>
+          <p:cNvPr id="5" name="TextBox 4"/>
+          <p:cNvSpPr txBox="1"/>
+          <p:nvPr/>
+        </p:nvSpPr>
+        <p:spPr>
+          <a:xfrm>
+            <a:off x="548640" y="6309360"/>
+            <a:ext cx="11094415" cy="411480"/>
+          </a:xfrm>
+          <a:prstGeom prst="rect">
+            <a:avLst/>
+          </a:prstGeom>
+          <a:noFill/>
+        </p:spPr>
+        <p:txBody>
+          <a:bodyPr wrap="square">
+            <a:spAutoFit/>
+          </a:bodyPr>
+          <a:lstStyle/>
+          <a:p>
+            <a:pPr algn="ctr"/>
+            <a:r>
+              <a:rPr sz="1300" i="1">
+                <a:solidFill>
+                  <a:srgbClr val="444444"/>
                 </a:solidFill>
                 <a:latin typeface="Calibri"/>
               </a:rPr>
-              <a:t>•  Exact match — identical integer cost (≫ exact-allocation match → ties)</a:t>
+              <a:t>green = closer to optimal · h256 better across the grid (esp. N=50) · M=75 is the hard column</a:t>
             </a:r>
           </a:p>
         </p:txBody>
@@ -6991,7 +7292,194 @@
                 </a:solidFill>
                 <a:latin typeface="Calibri"/>
               </a:rPr>
-              <a:t>(Backup) Limitations &amp; next steps</a:t>
+              <a:t>When to use the NN vs. the exact solver</a:t>
+            </a:r>
+          </a:p>
+        </p:txBody>
+      </p:sp>
+      <p:pic>
+        <p:nvPicPr>
+          <p:cNvPr id="3" name="Picture 2" descr="decision_table.png"/>
+          <p:cNvPicPr>
+            <a:picLocks noChangeAspect="1"/>
+          </p:cNvPicPr>
+          <p:nvPr/>
+        </p:nvPicPr>
+        <p:blipFill>
+          <a:blip r:embed="rId2"/>
+          <a:stretch>
+            <a:fillRect/>
+          </a:stretch>
+        </p:blipFill>
+        <p:spPr>
+          <a:xfrm>
+            <a:off x="548639" y="1380204"/>
+            <a:ext cx="11094415" cy="5103430"/>
+          </a:xfrm>
+          <a:prstGeom prst="rect">
+            <a:avLst/>
+          </a:prstGeom>
+        </p:spPr>
+      </p:pic>
+    </p:spTree>
+  </p:cSld>
+  <p:clrMapOvr>
+    <a:masterClrMapping/>
+  </p:clrMapOvr>
+</p:sld>
+</file>
+
+<file path=ppt/slides/slide25.xml><?xml version="1.0" encoding="utf-8"?>
+<p:sld xmlns:a="http://schemas.openxmlformats.org/drawingml/2006/main" xmlns:p="http://schemas.openxmlformats.org/presentationml/2006/main" xmlns:r="http://schemas.openxmlformats.org/officeDocument/2006/relationships">
+  <p:cSld>
+    <p:spTree>
+      <p:nvGrpSpPr>
+        <p:cNvPr id="1" name=""/>
+        <p:cNvGrpSpPr/>
+        <p:nvPr/>
+      </p:nvGrpSpPr>
+      <p:grpSpPr/>
+      <p:sp>
+        <p:nvSpPr>
+          <p:cNvPr id="2" name="TextBox 1"/>
+          <p:cNvSpPr txBox="1"/>
+          <p:nvPr/>
+        </p:nvSpPr>
+        <p:spPr>
+          <a:xfrm>
+            <a:off x="502920" y="292608"/>
+            <a:ext cx="11185855" cy="914400"/>
+          </a:xfrm>
+          <a:prstGeom prst="rect">
+            <a:avLst/>
+          </a:prstGeom>
+          <a:noFill/>
+        </p:spPr>
+        <p:txBody>
+          <a:bodyPr wrap="square">
+            <a:spAutoFit/>
+          </a:bodyPr>
+          <a:lstStyle/>
+          <a:p>
+            <a:r>
+              <a:rPr sz="3000" b="1">
+                <a:solidFill>
+                  <a:srgbClr val="1F497D"/>
+                </a:solidFill>
+                <a:latin typeface="Calibri"/>
+              </a:rPr>
+              <a:t>Demo: same instance, solver vs NN</a:t>
+            </a:r>
+          </a:p>
+        </p:txBody>
+      </p:sp>
+      <p:pic>
+        <p:nvPicPr>
+          <p:cNvPr id="3" name="Picture 2" descr="demo_run_compare.gif"/>
+          <p:cNvPicPr>
+            <a:picLocks noChangeAspect="1"/>
+          </p:cNvPicPr>
+          <p:nvPr/>
+        </p:nvPicPr>
+        <p:blipFill>
+          <a:blip r:embed="rId2"/>
+          <a:stretch>
+            <a:fillRect/>
+          </a:stretch>
+        </p:blipFill>
+        <p:spPr>
+          <a:xfrm>
+            <a:off x="1815312" y="1325880"/>
+            <a:ext cx="8561069" cy="4892040"/>
+          </a:xfrm>
+          <a:prstGeom prst="rect">
+            <a:avLst/>
+          </a:prstGeom>
+        </p:spPr>
+      </p:pic>
+      <p:sp>
+        <p:nvSpPr>
+          <p:cNvPr id="4" name="TextBox 3"/>
+          <p:cNvSpPr txBox="1"/>
+          <p:nvPr/>
+        </p:nvSpPr>
+        <p:spPr>
+          <a:xfrm>
+            <a:off x="548640" y="6309360"/>
+            <a:ext cx="11094415" cy="411480"/>
+          </a:xfrm>
+          <a:prstGeom prst="rect">
+            <a:avLst/>
+          </a:prstGeom>
+          <a:noFill/>
+        </p:spPr>
+        <p:txBody>
+          <a:bodyPr wrap="square">
+            <a:spAutoFit/>
+          </a:bodyPr>
+          <a:lstStyle/>
+          <a:p>
+            <a:pPr algn="ctr"/>
+            <a:r>
+              <a:rPr sz="1300" i="1">
+                <a:solidFill>
+                  <a:srgbClr val="444444"/>
+                </a:solidFill>
+                <a:latin typeface="Calibri"/>
+              </a:rPr>
+              <a:t>different allocation, identical cost (62) — the NN found its own equally-optimal plan</a:t>
+            </a:r>
+          </a:p>
+        </p:txBody>
+      </p:sp>
+    </p:spTree>
+  </p:cSld>
+  <p:clrMapOvr>
+    <a:masterClrMapping/>
+  </p:clrMapOvr>
+</p:sld>
+</file>
+
+<file path=ppt/slides/slide26.xml><?xml version="1.0" encoding="utf-8"?>
+<p:sld xmlns:a="http://schemas.openxmlformats.org/drawingml/2006/main" xmlns:p="http://schemas.openxmlformats.org/presentationml/2006/main" xmlns:r="http://schemas.openxmlformats.org/officeDocument/2006/relationships">
+  <p:cSld>
+    <p:spTree>
+      <p:nvGrpSpPr>
+        <p:cNvPr id="1" name=""/>
+        <p:cNvGrpSpPr/>
+        <p:nvPr/>
+      </p:nvGrpSpPr>
+      <p:grpSpPr/>
+      <p:sp>
+        <p:nvSpPr>
+          <p:cNvPr id="2" name="TextBox 1"/>
+          <p:cNvSpPr txBox="1"/>
+          <p:nvPr/>
+        </p:nvSpPr>
+        <p:spPr>
+          <a:xfrm>
+            <a:off x="502920" y="292608"/>
+            <a:ext cx="11185855" cy="914400"/>
+          </a:xfrm>
+          <a:prstGeom prst="rect">
+            <a:avLst/>
+          </a:prstGeom>
+          <a:noFill/>
+        </p:spPr>
+        <p:txBody>
+          <a:bodyPr wrap="square">
+            <a:spAutoFit/>
+          </a:bodyPr>
+          <a:lstStyle/>
+          <a:p>
+            <a:r>
+              <a:rPr sz="3000" b="1">
+                <a:solidFill>
+                  <a:srgbClr val="1F497D"/>
+                </a:solidFill>
+                <a:latin typeface="Calibri"/>
+              </a:rPr>
+              <a:t>Conclusion</a:t>
             </a:r>
           </a:p>
         </p:txBody>
@@ -7030,7 +7518,7 @@
                 </a:solidFill>
                 <a:latin typeface="Calibri"/>
               </a:rPr>
-              <a:t>•  brute-force goal ordering is O(k!) — mitigated by nearest-neighbor + 2-opt fallback</a:t>
+              <a:t>•  Problem: optimal allocation (mTSP in MAPF) — combinatorial step scales badly</a:t>
             </a:r>
           </a:p>
           <a:p>
@@ -7046,7 +7534,7 @@
                 </a:solidFill>
                 <a:latin typeface="Calibri"/>
               </a:rPr>
-              <a:t>•  CBS execution cost is not differentiable</a:t>
+              <a:t>•  Idea: a small universal transformer imitates it from distances — near-optimal</a:t>
             </a:r>
           </a:p>
           <a:p>
@@ -7062,11 +7550,333 @@
                 </a:solidFill>
                 <a:latin typeface="Calibri"/>
               </a:rPr>
-              <a:t>•  next: tour-aware loss · learned goal-ordering head</a:t>
-            </a:r>
-          </a:p>
-        </p:txBody>
-      </p:sp>
+              <a:t>•  Generalizes: any N,M; across scale and (with the right data) geometry</a:t>
+            </a:r>
+          </a:p>
+          <a:p>
+            <a:pPr>
+              <a:spcAft>
+                <a:spcPts val="400"/>
+              </a:spcAft>
+            </a:pPr>
+            <a:r>
+              <a:rPr sz="2000">
+                <a:solidFill>
+                  <a:srgbClr val="222222"/>
+                </a:solidFill>
+                <a:latin typeface="Calibri"/>
+              </a:rPr>
+              <a:t>•  Payoff: 5.9–9.4× at scale, within ~20% of optimal — use where speed/scale matter</a:t>
+            </a:r>
+          </a:p>
+        </p:txBody>
+      </p:sp>
+    </p:spTree>
+  </p:cSld>
+  <p:clrMapOvr>
+    <a:masterClrMapping/>
+  </p:clrMapOvr>
+</p:sld>
+</file>
+
+<file path=ppt/slides/slide27.xml><?xml version="1.0" encoding="utf-8"?>
+<p:sld xmlns:a="http://schemas.openxmlformats.org/drawingml/2006/main" xmlns:p="http://schemas.openxmlformats.org/presentationml/2006/main" xmlns:r="http://schemas.openxmlformats.org/officeDocument/2006/relationships">
+  <p:cSld>
+    <p:spTree>
+      <p:nvGrpSpPr>
+        <p:cNvPr id="1" name=""/>
+        <p:cNvGrpSpPr/>
+        <p:nvPr/>
+      </p:nvGrpSpPr>
+      <p:grpSpPr/>
+      <p:sp>
+        <p:nvSpPr>
+          <p:cNvPr id="2" name="TextBox 1"/>
+          <p:cNvSpPr txBox="1"/>
+          <p:nvPr/>
+        </p:nvSpPr>
+        <p:spPr>
+          <a:xfrm>
+            <a:off x="502920" y="292608"/>
+            <a:ext cx="11185855" cy="914400"/>
+          </a:xfrm>
+          <a:prstGeom prst="rect">
+            <a:avLst/>
+          </a:prstGeom>
+          <a:noFill/>
+        </p:spPr>
+        <p:txBody>
+          <a:bodyPr wrap="square">
+            <a:spAutoFit/>
+          </a:bodyPr>
+          <a:lstStyle/>
+          <a:p>
+            <a:r>
+              <a:rPr sz="3000" b="1">
+                <a:solidFill>
+                  <a:srgbClr val="1F497D"/>
+                </a:solidFill>
+                <a:latin typeface="Calibri"/>
+              </a:rPr>
+              <a:t>Thank you — questions?</a:t>
+            </a:r>
+          </a:p>
+        </p:txBody>
+      </p:sp>
+      <p:sp>
+        <p:nvSpPr>
+          <p:cNvPr id="3" name="TextBox 2"/>
+          <p:cNvSpPr txBox="1"/>
+          <p:nvPr/>
+        </p:nvSpPr>
+        <p:spPr>
+          <a:xfrm>
+            <a:off x="640080" y="1325880"/>
+            <a:ext cx="10911535" cy="1143000"/>
+          </a:xfrm>
+          <a:prstGeom prst="rect">
+            <a:avLst/>
+          </a:prstGeom>
+          <a:noFill/>
+        </p:spPr>
+        <p:txBody>
+          <a:bodyPr wrap="square">
+            <a:spAutoFit/>
+          </a:bodyPr>
+          <a:lstStyle/>
+          <a:p>
+            <a:pPr>
+              <a:spcAft>
+                <a:spcPts val="400"/>
+              </a:spcAft>
+            </a:pPr>
+            <a:r>
+              <a:rPr sz="2000">
+                <a:solidFill>
+                  <a:srgbClr val="222222"/>
+                </a:solidFill>
+                <a:latin typeface="Calibri"/>
+              </a:rPr>
+              <a:t>•  Acknowledgment: the RobustMCPF solver (LKH + CBS) is the work of Yehonatan Kidushim (github.com/yehonatan280198)</a:t>
+            </a:r>
+          </a:p>
+          <a:p>
+            <a:pPr>
+              <a:spcAft>
+                <a:spcPts val="400"/>
+              </a:spcAft>
+            </a:pPr>
+            <a:r>
+              <a:rPr sz="2000">
+                <a:solidFill>
+                  <a:srgbClr val="222222"/>
+                </a:solidFill>
+                <a:latin typeface="Calibri"/>
+              </a:rPr>
+              <a:t>•  repo: Neural_MCPF_Allocation · RobustMCPF (LKH + CBS)</a:t>
+            </a:r>
+          </a:p>
+        </p:txBody>
+      </p:sp>
+    </p:spTree>
+  </p:cSld>
+  <p:clrMapOvr>
+    <a:masterClrMapping/>
+  </p:clrMapOvr>
+</p:sld>
+</file>
+
+<file path=ppt/slides/slide28.xml><?xml version="1.0" encoding="utf-8"?>
+<p:sld xmlns:a="http://schemas.openxmlformats.org/drawingml/2006/main" xmlns:p="http://schemas.openxmlformats.org/presentationml/2006/main" xmlns:r="http://schemas.openxmlformats.org/officeDocument/2006/relationships">
+  <p:cSld>
+    <p:spTree>
+      <p:nvGrpSpPr>
+        <p:cNvPr id="1" name=""/>
+        <p:cNvGrpSpPr/>
+        <p:nvPr/>
+      </p:nvGrpSpPr>
+      <p:grpSpPr/>
+      <p:sp>
+        <p:nvSpPr>
+          <p:cNvPr id="2" name="TextBox 1"/>
+          <p:cNvSpPr txBox="1"/>
+          <p:nvPr/>
+        </p:nvSpPr>
+        <p:spPr>
+          <a:xfrm>
+            <a:off x="502920" y="292608"/>
+            <a:ext cx="11185855" cy="914400"/>
+          </a:xfrm>
+          <a:prstGeom prst="rect">
+            <a:avLst/>
+          </a:prstGeom>
+          <a:noFill/>
+        </p:spPr>
+        <p:txBody>
+          <a:bodyPr wrap="square">
+            <a:spAutoFit/>
+          </a:bodyPr>
+          <a:lstStyle/>
+          <a:p>
+            <a:r>
+              <a:rPr sz="3000" b="1">
+                <a:solidFill>
+                  <a:srgbClr val="1F497D"/>
+                </a:solidFill>
+                <a:latin typeface="Calibri"/>
+              </a:rPr>
+              <a:t>(Extra) Loss</a:t>
+            </a:r>
+          </a:p>
+        </p:txBody>
+      </p:sp>
+      <p:sp>
+        <p:nvSpPr>
+          <p:cNvPr id="3" name="TextBox 2"/>
+          <p:cNvSpPr txBox="1"/>
+          <p:nvPr/>
+        </p:nvSpPr>
+        <p:spPr>
+          <a:xfrm>
+            <a:off x="640080" y="1325880"/>
+            <a:ext cx="10911535" cy="1143000"/>
+          </a:xfrm>
+          <a:prstGeom prst="rect">
+            <a:avLst/>
+          </a:prstGeom>
+          <a:noFill/>
+        </p:spPr>
+        <p:txBody>
+          <a:bodyPr wrap="square">
+            <a:spAutoFit/>
+          </a:bodyPr>
+          <a:lstStyle/>
+          <a:p>
+            <a:pPr>
+              <a:spcAft>
+                <a:spcPts val="400"/>
+              </a:spcAft>
+            </a:pPr>
+            <a:r>
+              <a:rPr sz="2000">
+                <a:solidFill>
+                  <a:srgbClr val="222222"/>
+                </a:solidFill>
+                <a:latin typeface="Calibri"/>
+              </a:rPr>
+              <a:t>•  L = L_CE + λ·L_MinSum   (λ = 0.1)</a:t>
+            </a:r>
+          </a:p>
+          <a:p>
+            <a:pPr>
+              <a:spcAft>
+                <a:spcPts val="400"/>
+              </a:spcAft>
+            </a:pPr>
+            <a:r>
+              <a:rPr sz="2000">
+                <a:solidFill>
+                  <a:srgbClr val="222222"/>
+                </a:solidFill>
+                <a:latin typeface="Calibri"/>
+              </a:rPr>
+              <a:t>•  CE — per-goal cross-entropy vs the solver (imitation)</a:t>
+            </a:r>
+          </a:p>
+          <a:p>
+            <a:pPr>
+              <a:spcAft>
+                <a:spcPts val="400"/>
+              </a:spcAft>
+            </a:pPr>
+            <a:r>
+              <a:rPr sz="2000">
+                <a:solidFill>
+                  <a:srgbClr val="222222"/>
+                </a:solidFill>
+                <a:latin typeface="Calibri"/>
+              </a:rPr>
+              <a:t>•  MinSum = Σ P·D — mild geometric regularizer</a:t>
+            </a:r>
+          </a:p>
+        </p:txBody>
+      </p:sp>
+    </p:spTree>
+  </p:cSld>
+  <p:clrMapOvr>
+    <a:masterClrMapping/>
+  </p:clrMapOvr>
+</p:sld>
+</file>
+
+<file path=ppt/slides/slide29.xml><?xml version="1.0" encoding="utf-8"?>
+<p:sld xmlns:a="http://schemas.openxmlformats.org/drawingml/2006/main" xmlns:p="http://schemas.openxmlformats.org/presentationml/2006/main" xmlns:r="http://schemas.openxmlformats.org/officeDocument/2006/relationships">
+  <p:cSld>
+    <p:spTree>
+      <p:nvGrpSpPr>
+        <p:cNvPr id="1" name=""/>
+        <p:cNvGrpSpPr/>
+        <p:nvPr/>
+      </p:nvGrpSpPr>
+      <p:grpSpPr/>
+      <p:sp>
+        <p:nvSpPr>
+          <p:cNvPr id="2" name="TextBox 1"/>
+          <p:cNvSpPr txBox="1"/>
+          <p:nvPr/>
+        </p:nvSpPr>
+        <p:spPr>
+          <a:xfrm>
+            <a:off x="502920" y="292608"/>
+            <a:ext cx="11185855" cy="914400"/>
+          </a:xfrm>
+          <a:prstGeom prst="rect">
+            <a:avLst/>
+          </a:prstGeom>
+          <a:noFill/>
+        </p:spPr>
+        <p:txBody>
+          <a:bodyPr wrap="square">
+            <a:spAutoFit/>
+          </a:bodyPr>
+          <a:lstStyle/>
+          <a:p>
+            <a:r>
+              <a:rPr sz="3000" b="1">
+                <a:solidFill>
+                  <a:srgbClr val="1F497D"/>
+                </a:solidFill>
+                <a:latin typeface="Calibri"/>
+              </a:rPr>
+              <a:t>(Extra) Overfitting &amp; small-vs-big</a:t>
+            </a:r>
+          </a:p>
+        </p:txBody>
+      </p:sp>
+      <p:pic>
+        <p:nvPicPr>
+          <p:cNvPr id="3" name="Picture 2" descr="convergence.png"/>
+          <p:cNvPicPr>
+            <a:picLocks noChangeAspect="1"/>
+          </p:cNvPicPr>
+          <p:nvPr/>
+        </p:nvPicPr>
+        <p:blipFill>
+          <a:blip r:embed="rId2"/>
+          <a:stretch>
+            <a:fillRect/>
+          </a:stretch>
+        </p:blipFill>
+        <p:spPr>
+          <a:xfrm>
+            <a:off x="548639" y="1772786"/>
+            <a:ext cx="11094415" cy="4318266"/>
+          </a:xfrm>
+          <a:prstGeom prst="rect">
+            <a:avLst/>
+          </a:prstGeom>
+        </p:spPr>
+      </p:pic>
     </p:spTree>
   </p:cSld>
   <p:clrMapOvr>
@@ -7206,6 +8016,129 @@
 </p:sld>
 </file>
 
+<file path=ppt/slides/slide30.xml><?xml version="1.0" encoding="utf-8"?>
+<p:sld xmlns:a="http://schemas.openxmlformats.org/drawingml/2006/main" xmlns:p="http://schemas.openxmlformats.org/presentationml/2006/main" xmlns:r="http://schemas.openxmlformats.org/officeDocument/2006/relationships">
+  <p:cSld>
+    <p:spTree>
+      <p:nvGrpSpPr>
+        <p:cNvPr id="1" name=""/>
+        <p:cNvGrpSpPr/>
+        <p:nvPr/>
+      </p:nvGrpSpPr>
+      <p:grpSpPr/>
+      <p:sp>
+        <p:nvSpPr>
+          <p:cNvPr id="2" name="TextBox 1"/>
+          <p:cNvSpPr txBox="1"/>
+          <p:nvPr/>
+        </p:nvSpPr>
+        <p:spPr>
+          <a:xfrm>
+            <a:off x="502920" y="292608"/>
+            <a:ext cx="11185855" cy="914400"/>
+          </a:xfrm>
+          <a:prstGeom prst="rect">
+            <a:avLst/>
+          </a:prstGeom>
+          <a:noFill/>
+        </p:spPr>
+        <p:txBody>
+          <a:bodyPr wrap="square">
+            <a:spAutoFit/>
+          </a:bodyPr>
+          <a:lstStyle/>
+          <a:p>
+            <a:r>
+              <a:rPr sz="3000" b="1">
+                <a:solidFill>
+                  <a:srgbClr val="1F497D"/>
+                </a:solidFill>
+                <a:latin typeface="Calibri"/>
+              </a:rPr>
+              <a:t>(Extra) Metrics</a:t>
+            </a:r>
+          </a:p>
+        </p:txBody>
+      </p:sp>
+      <p:sp>
+        <p:nvSpPr>
+          <p:cNvPr id="3" name="TextBox 2"/>
+          <p:cNvSpPr txBox="1"/>
+          <p:nvPr/>
+        </p:nvSpPr>
+        <p:spPr>
+          <a:xfrm>
+            <a:off x="640080" y="1325880"/>
+            <a:ext cx="10911535" cy="1143000"/>
+          </a:xfrm>
+          <a:prstGeom prst="rect">
+            <a:avLst/>
+          </a:prstGeom>
+          <a:noFill/>
+        </p:spPr>
+        <p:txBody>
+          <a:bodyPr wrap="square">
+            <a:spAutoFit/>
+          </a:bodyPr>
+          <a:lstStyle/>
+          <a:p>
+            <a:pPr>
+              <a:spcAft>
+                <a:spcPts val="400"/>
+              </a:spcAft>
+            </a:pPr>
+            <a:r>
+              <a:rPr sz="2000">
+                <a:solidFill>
+                  <a:srgbClr val="222222"/>
+                </a:solidFill>
+                <a:latin typeface="Calibri"/>
+              </a:rPr>
+              <a:t>•  Offline — allocation agreement (per-goal / full-assignment accuracy)</a:t>
+            </a:r>
+          </a:p>
+          <a:p>
+            <a:pPr>
+              <a:spcAft>
+                <a:spcPts val="400"/>
+              </a:spcAft>
+            </a:pPr>
+            <a:r>
+              <a:rPr sz="2000">
+                <a:solidFill>
+                  <a:srgbClr val="222222"/>
+                </a:solidFill>
+                <a:latin typeface="Calibri"/>
+              </a:rPr>
+              <a:t>•  Execution cost — true CBS path-length ratio (NN / solver)</a:t>
+            </a:r>
+          </a:p>
+          <a:p>
+            <a:pPr>
+              <a:spcAft>
+                <a:spcPts val="400"/>
+              </a:spcAft>
+            </a:pPr>
+            <a:r>
+              <a:rPr sz="2000">
+                <a:solidFill>
+                  <a:srgbClr val="222222"/>
+                </a:solidFill>
+                <a:latin typeface="Calibri"/>
+              </a:rPr>
+              <a:t>•  Exact match — identical integer cost (≫ exact-allocation match → ties)</a:t>
+            </a:r>
+          </a:p>
+        </p:txBody>
+      </p:sp>
+    </p:spTree>
+  </p:cSld>
+  <p:clrMapOvr>
+    <a:masterClrMapping/>
+  </p:clrMapOvr>
+</p:sld>
+</file>
+
 <file path=ppt/slides/slide4.xml><?xml version="1.0" encoding="utf-8"?>
 <p:sld xmlns:a="http://schemas.openxmlformats.org/drawingml/2006/main" xmlns:p="http://schemas.openxmlformats.org/presentationml/2006/main" xmlns:r="http://schemas.openxmlformats.org/officeDocument/2006/relationships">
   <p:cSld>
@@ -7439,7 +8372,23 @@
                 </a:solidFill>
                 <a:latin typeface="Calibri"/>
               </a:rPr>
-              <a:t>•  Expected: imitate the solver + a big speedup, especially at scale</a:t>
+              <a:t>•  Expected: imitate the solver → big speedup, especially at scale</a:t>
+            </a:r>
+          </a:p>
+          <a:p>
+            <a:pPr>
+              <a:spcAft>
+                <a:spcPts val="400"/>
+              </a:spcAft>
+            </a:pPr>
+            <a:r>
+              <a:rPr sz="2000">
+                <a:solidFill>
+                  <a:srgbClr val="222222"/>
+                </a:solidFill>
+                <a:latin typeface="Calibri"/>
+              </a:rPr>
+              <a:t>•  Accept suboptimal solutions — the NN won't always find the optimum</a:t>
             </a:r>
           </a:p>
         </p:txBody>
@@ -7660,6 +8609,22 @@
               <a:t>•  distances, not coordinates</a:t>
             </a:r>
           </a:p>
+          <a:p>
+            <a:pPr>
+              <a:spcAft>
+                <a:spcPts val="400"/>
+              </a:spcAft>
+            </a:pPr>
+            <a:r>
+              <a:rPr sz="2000">
+                <a:solidFill>
+                  <a:srgbClr val="222222"/>
+                </a:solidFill>
+                <a:latin typeface="Calibri"/>
+              </a:rPr>
+              <a:t>•  same distances as LKH-TSP — but two matrices (D, G), not one big cost table</a:t>
+            </a:r>
+          </a:p>
         </p:txBody>
       </p:sp>
       <p:pic>
@@ -7678,8 +8643,8 @@
         </p:blipFill>
         <p:spPr>
           <a:xfrm>
-            <a:off x="1456410" y="2414016"/>
-            <a:ext cx="9278874" cy="4123944"/>
+            <a:off x="1888464" y="2798064"/>
+            <a:ext cx="8414766" cy="3739896"/>
           </a:xfrm>
           <a:prstGeom prst="rect">
             <a:avLst/>
@@ -7772,7 +8737,7 @@
                 </a:solidFill>
                 <a:latin typeface="Calibri"/>
               </a:rPr>
-              <a:t>•  universal transformer: row attention (agent↔goals) · column attention (goal↔agents)</a:t>
+              <a:t>•  row attention — each agent attends over its goals</a:t>
             </a:r>
           </a:p>
           <a:p>
@@ -7788,7 +8753,39 @@
                 </a:solidFill>
                 <a:latin typeface="Calibri"/>
               </a:rPr>
-              <a:t>•  column-softmax output · loss = CE + λ·MinSum</a:t>
+              <a:t>•  column attention — each goal attends over its agents</a:t>
+            </a:r>
+          </a:p>
+          <a:p>
+            <a:pPr>
+              <a:spcAft>
+                <a:spcPts val="400"/>
+              </a:spcAft>
+            </a:pPr>
+            <a:r>
+              <a:rPr sz="2000">
+                <a:solidFill>
+                  <a:srgbClr val="222222"/>
+                </a:solidFill>
+                <a:latin typeface="Calibri"/>
+              </a:rPr>
+              <a:t>•  per block: row × column attention + FFN, repeated ×L</a:t>
+            </a:r>
+          </a:p>
+          <a:p>
+            <a:pPr>
+              <a:spcAft>
+                <a:spcPts val="400"/>
+              </a:spcAft>
+            </a:pPr>
+            <a:r>
+              <a:rPr sz="2000">
+                <a:solidFill>
+                  <a:srgbClr val="222222"/>
+                </a:solidFill>
+                <a:latin typeface="Calibri"/>
+              </a:rPr>
+              <a:t>•  output: column softmax  ·  loss = CE + λ·MinSum</a:t>
             </a:r>
           </a:p>
         </p:txBody>
@@ -7809,8 +8806,8 @@
         </p:blipFill>
         <p:spPr>
           <a:xfrm>
-            <a:off x="2659227" y="2414016"/>
-            <a:ext cx="6873240" cy="4123944"/>
+            <a:off x="3299307" y="3182112"/>
+            <a:ext cx="5593080" cy="3355848"/>
           </a:xfrm>
           <a:prstGeom prst="rect">
             <a:avLst/>

</xml_diff>